<commit_message>
feat: inclui Juliano Barbosa Paixao (RA 2041952) no grupo e redistribui apresentacao
- Adiciona Juliano ao grupo (5 integrantes)
- Nova distribuicao balanceada: Willian (1,2,3,7,16), Juliano (4,5,6),
  Karoline (8,9), Ana Caroline (10,11,12), Erick (13,14,15)
- Atualiza script_apresentacao.md com falas e tags de cada membro
- Regenera Central_Elevador.pptx com 5 cards de cor por membro e
  barras de parte corretas em todos os slides

Co-Authored-By: Claude Sonnet 4.6 (1M context) <noreply@anthropic.com>
</commit_message>
<xml_diff>
--- a/Central_Elevador.pptx
+++ b/Central_Elevador.pptx
@@ -3275,8 +3275,8 @@
         </p:nvSpPr>
         <p:spPr>
           <a:xfrm>
-            <a:off x="274320" y="3200400"/>
-            <a:ext cx="2743200" cy="2011680"/>
+            <a:off x="182880" y="3200400"/>
+            <a:ext cx="2194560" cy="2011680"/>
           </a:xfrm>
           <a:prstGeom prst="rect">
             <a:avLst/>
@@ -3318,8 +3318,8 @@
         </p:nvSpPr>
         <p:spPr>
           <a:xfrm>
-            <a:off x="274320" y="3200400"/>
-            <a:ext cx="2743200" cy="64008"/>
+            <a:off x="182880" y="3200400"/>
+            <a:ext cx="2194560" cy="64008"/>
           </a:xfrm>
           <a:prstGeom prst="rect">
             <a:avLst/>
@@ -3361,8 +3361,8 @@
         </p:nvSpPr>
         <p:spPr>
           <a:xfrm>
-            <a:off x="384048" y="3291840"/>
-            <a:ext cx="2560320" cy="1097280"/>
+            <a:off x="274320" y="3291840"/>
+            <a:ext cx="2011680" cy="1097280"/>
           </a:xfrm>
           <a:prstGeom prst="rect">
             <a:avLst/>
@@ -3377,7 +3377,7 @@
           <a:p>
             <a:pPr algn="ctr"/>
             <a:r>
-              <a:rPr sz="1300" b="1" i="0">
+              <a:rPr sz="1100" b="1" i="0">
                 <a:solidFill>
                   <a:srgbClr val="FFFFFF"/>
                 </a:solidFill>
@@ -3396,8 +3396,8 @@
         </p:nvSpPr>
         <p:spPr>
           <a:xfrm>
-            <a:off x="384048" y="4297680"/>
-            <a:ext cx="2560320" cy="411480"/>
+            <a:off x="274320" y="4297680"/>
+            <a:ext cx="2011680" cy="411480"/>
           </a:xfrm>
           <a:prstGeom prst="rect">
             <a:avLst/>
@@ -3412,7 +3412,7 @@
           <a:p>
             <a:pPr algn="ctr"/>
             <a:r>
-              <a:rPr sz="1300" b="1" i="0">
+              <a:rPr sz="1200" b="1" i="0">
                 <a:solidFill>
                   <a:srgbClr val="58A6FF"/>
                 </a:solidFill>
@@ -3431,8 +3431,8 @@
         </p:nvSpPr>
         <p:spPr>
           <a:xfrm>
-            <a:off x="3291840" y="3200400"/>
-            <a:ext cx="2743200" cy="2011680"/>
+            <a:off x="2560320" y="3200400"/>
+            <a:ext cx="2194560" cy="2011680"/>
           </a:xfrm>
           <a:prstGeom prst="rect">
             <a:avLst/>
@@ -3474,14 +3474,14 @@
         </p:nvSpPr>
         <p:spPr>
           <a:xfrm>
-            <a:off x="3291840" y="3200400"/>
-            <a:ext cx="2743200" cy="64008"/>
-          </a:xfrm>
-          <a:prstGeom prst="rect">
-            <a:avLst/>
-          </a:prstGeom>
-          <a:solidFill>
-            <a:srgbClr val="BB87FF"/>
+            <a:off x="2560320" y="3200400"/>
+            <a:ext cx="2194560" cy="64008"/>
+          </a:xfrm>
+          <a:prstGeom prst="rect">
+            <a:avLst/>
+          </a:prstGeom>
+          <a:solidFill>
+            <a:srgbClr val="F9A825"/>
           </a:solidFill>
           <a:ln>
             <a:noFill/>
@@ -3517,8 +3517,8 @@
         </p:nvSpPr>
         <p:spPr>
           <a:xfrm>
-            <a:off x="3401568" y="3291840"/>
-            <a:ext cx="2560320" cy="1097280"/>
+            <a:off x="2651760" y="3291840"/>
+            <a:ext cx="2011680" cy="1097280"/>
           </a:xfrm>
           <a:prstGeom prst="rect">
             <a:avLst/>
@@ -3533,13 +3533,13 @@
           <a:p>
             <a:pPr algn="ctr"/>
             <a:r>
-              <a:rPr sz="1300" b="1" i="0">
+              <a:rPr sz="1100" b="1" i="0">
                 <a:solidFill>
                   <a:srgbClr val="FFFFFF"/>
                 </a:solidFill>
                 <a:latin typeface="Segoe UI"/>
               </a:rPr>
-              <a:t>Karoline Vitória de Freitas Yang</a:t>
+              <a:t>Juliano Barbosa Paixão</a:t>
             </a:r>
           </a:p>
         </p:txBody>
@@ -3552,8 +3552,8 @@
         </p:nvSpPr>
         <p:spPr>
           <a:xfrm>
-            <a:off x="3401568" y="4297680"/>
-            <a:ext cx="2560320" cy="411480"/>
+            <a:off x="2651760" y="4297680"/>
+            <a:ext cx="2011680" cy="411480"/>
           </a:xfrm>
           <a:prstGeom prst="rect">
             <a:avLst/>
@@ -3568,13 +3568,13 @@
           <a:p>
             <a:pPr algn="ctr"/>
             <a:r>
-              <a:rPr sz="1300" b="1" i="0">
-                <a:solidFill>
-                  <a:srgbClr val="BB87FF"/>
-                </a:solidFill>
-                <a:latin typeface="Segoe UI"/>
-              </a:rPr>
-              <a:t>RA 2578000</a:t>
+              <a:rPr sz="1200" b="1" i="0">
+                <a:solidFill>
+                  <a:srgbClr val="F9A825"/>
+                </a:solidFill>
+                <a:latin typeface="Segoe UI"/>
+              </a:rPr>
+              <a:t>RA 2041952</a:t>
             </a:r>
           </a:p>
         </p:txBody>
@@ -3587,8 +3587,8 @@
         </p:nvSpPr>
         <p:spPr>
           <a:xfrm>
-            <a:off x="6309360" y="3200400"/>
-            <a:ext cx="2743200" cy="2011680"/>
+            <a:off x="4937760" y="3200400"/>
+            <a:ext cx="2194560" cy="2011680"/>
           </a:xfrm>
           <a:prstGeom prst="rect">
             <a:avLst/>
@@ -3630,14 +3630,14 @@
         </p:nvSpPr>
         <p:spPr>
           <a:xfrm>
-            <a:off x="6309360" y="3200400"/>
-            <a:ext cx="2743200" cy="64008"/>
-          </a:xfrm>
-          <a:prstGeom prst="rect">
-            <a:avLst/>
-          </a:prstGeom>
-          <a:solidFill>
-            <a:srgbClr val="3FB950"/>
+            <a:off x="4937760" y="3200400"/>
+            <a:ext cx="2194560" cy="64008"/>
+          </a:xfrm>
+          <a:prstGeom prst="rect">
+            <a:avLst/>
+          </a:prstGeom>
+          <a:solidFill>
+            <a:srgbClr val="BB87FF"/>
           </a:solidFill>
           <a:ln>
             <a:noFill/>
@@ -3673,8 +3673,8 @@
         </p:nvSpPr>
         <p:spPr>
           <a:xfrm>
-            <a:off x="6419088" y="3291840"/>
-            <a:ext cx="2560320" cy="1097280"/>
+            <a:off x="5029200" y="3291840"/>
+            <a:ext cx="2011680" cy="1097280"/>
           </a:xfrm>
           <a:prstGeom prst="rect">
             <a:avLst/>
@@ -3689,13 +3689,13 @@
           <a:p>
             <a:pPr algn="ctr"/>
             <a:r>
-              <a:rPr sz="1300" b="1" i="0">
+              <a:rPr sz="1100" b="1" i="0">
                 <a:solidFill>
                   <a:srgbClr val="FFFFFF"/>
                 </a:solidFill>
                 <a:latin typeface="Segoe UI"/>
               </a:rPr>
-              <a:t>Ana Caroline Soares Baptista</a:t>
+              <a:t>Karoline Vitória de Freitas Yang</a:t>
             </a:r>
           </a:p>
         </p:txBody>
@@ -3708,8 +3708,8 @@
         </p:nvSpPr>
         <p:spPr>
           <a:xfrm>
-            <a:off x="6419088" y="4297680"/>
-            <a:ext cx="2560320" cy="411480"/>
+            <a:off x="5029200" y="4297680"/>
+            <a:ext cx="2011680" cy="411480"/>
           </a:xfrm>
           <a:prstGeom prst="rect">
             <a:avLst/>
@@ -3724,13 +3724,13 @@
           <a:p>
             <a:pPr algn="ctr"/>
             <a:r>
-              <a:rPr sz="1300" b="1" i="0">
-                <a:solidFill>
-                  <a:srgbClr val="3FB950"/>
-                </a:solidFill>
-                <a:latin typeface="Segoe UI"/>
-              </a:rPr>
-              <a:t>RA 2486024</a:t>
+              <a:rPr sz="1200" b="1" i="0">
+                <a:solidFill>
+                  <a:srgbClr val="BB87FF"/>
+                </a:solidFill>
+                <a:latin typeface="Segoe UI"/>
+              </a:rPr>
+              <a:t>RA 2578000</a:t>
             </a:r>
           </a:p>
         </p:txBody>
@@ -3743,8 +3743,8 @@
         </p:nvSpPr>
         <p:spPr>
           <a:xfrm>
-            <a:off x="9144000" y="3200400"/>
-            <a:ext cx="2743200" cy="2011680"/>
+            <a:off x="7315200" y="3200400"/>
+            <a:ext cx="2194560" cy="2011680"/>
           </a:xfrm>
           <a:prstGeom prst="rect">
             <a:avLst/>
@@ -3786,14 +3786,14 @@
         </p:nvSpPr>
         <p:spPr>
           <a:xfrm>
-            <a:off x="9144000" y="3200400"/>
-            <a:ext cx="2743200" cy="64008"/>
-          </a:xfrm>
-          <a:prstGeom prst="rect">
-            <a:avLst/>
-          </a:prstGeom>
-          <a:solidFill>
-            <a:srgbClr val="FF7B72"/>
+            <a:off x="7315200" y="3200400"/>
+            <a:ext cx="2194560" cy="64008"/>
+          </a:xfrm>
+          <a:prstGeom prst="rect">
+            <a:avLst/>
+          </a:prstGeom>
+          <a:solidFill>
+            <a:srgbClr val="3FB950"/>
           </a:solidFill>
           <a:ln>
             <a:noFill/>
@@ -3829,8 +3829,8 @@
         </p:nvSpPr>
         <p:spPr>
           <a:xfrm>
-            <a:off x="9253728" y="3291840"/>
-            <a:ext cx="2560320" cy="1097280"/>
+            <a:off x="7406640" y="3291840"/>
+            <a:ext cx="2011680" cy="1097280"/>
           </a:xfrm>
           <a:prstGeom prst="rect">
             <a:avLst/>
@@ -3845,13 +3845,13 @@
           <a:p>
             <a:pPr algn="ctr"/>
             <a:r>
-              <a:rPr sz="1300" b="1" i="0">
+              <a:rPr sz="1100" b="1" i="0">
                 <a:solidFill>
                   <a:srgbClr val="FFFFFF"/>
                 </a:solidFill>
                 <a:latin typeface="Segoe UI"/>
               </a:rPr>
-              <a:t>Erick Rodrigues Villalva</a:t>
+              <a:t>Ana Caroline Soares Baptista</a:t>
             </a:r>
           </a:p>
         </p:txBody>
@@ -3864,8 +3864,8 @@
         </p:nvSpPr>
         <p:spPr>
           <a:xfrm>
-            <a:off x="9253728" y="4297680"/>
-            <a:ext cx="2560320" cy="411480"/>
+            <a:off x="7406640" y="4297680"/>
+            <a:ext cx="2011680" cy="411480"/>
           </a:xfrm>
           <a:prstGeom prst="rect">
             <a:avLst/>
@@ -3880,7 +3880,163 @@
           <a:p>
             <a:pPr algn="ctr"/>
             <a:r>
-              <a:rPr sz="1300" b="1" i="0">
+              <a:rPr sz="1200" b="1" i="0">
+                <a:solidFill>
+                  <a:srgbClr val="3FB950"/>
+                </a:solidFill>
+                <a:latin typeface="Segoe UI"/>
+              </a:rPr>
+              <a:t>RA 2486024</a:t>
+            </a:r>
+          </a:p>
+        </p:txBody>
+      </p:sp>
+      <p:sp>
+        <p:nvSpPr>
+          <p:cNvPr id="22" name="Rectangle 21"/>
+          <p:cNvSpPr/>
+          <p:nvPr/>
+        </p:nvSpPr>
+        <p:spPr>
+          <a:xfrm>
+            <a:off x="9692640" y="3200400"/>
+            <a:ext cx="2194560" cy="2011680"/>
+          </a:xfrm>
+          <a:prstGeom prst="rect">
+            <a:avLst/>
+          </a:prstGeom>
+          <a:solidFill>
+            <a:srgbClr val="161B22"/>
+          </a:solidFill>
+          <a:ln>
+            <a:noFill/>
+          </a:ln>
+        </p:spPr>
+        <p:style>
+          <a:lnRef idx="1">
+            <a:schemeClr val="accent1"/>
+          </a:lnRef>
+          <a:fillRef idx="3">
+            <a:schemeClr val="accent1"/>
+          </a:fillRef>
+          <a:effectRef idx="2">
+            <a:schemeClr val="accent1"/>
+          </a:effectRef>
+          <a:fontRef idx="minor">
+            <a:schemeClr val="lt1"/>
+          </a:fontRef>
+        </p:style>
+        <p:txBody>
+          <a:bodyPr rtlCol="0" anchor="ctr"/>
+          <a:lstStyle/>
+          <a:p>
+            <a:pPr algn="ctr"/>
+          </a:p>
+        </p:txBody>
+      </p:sp>
+      <p:sp>
+        <p:nvSpPr>
+          <p:cNvPr id="23" name="Rectangle 22"/>
+          <p:cNvSpPr/>
+          <p:nvPr/>
+        </p:nvSpPr>
+        <p:spPr>
+          <a:xfrm>
+            <a:off x="9692640" y="3200400"/>
+            <a:ext cx="2194560" cy="64008"/>
+          </a:xfrm>
+          <a:prstGeom prst="rect">
+            <a:avLst/>
+          </a:prstGeom>
+          <a:solidFill>
+            <a:srgbClr val="FF7B72"/>
+          </a:solidFill>
+          <a:ln>
+            <a:noFill/>
+          </a:ln>
+        </p:spPr>
+        <p:style>
+          <a:lnRef idx="1">
+            <a:schemeClr val="accent1"/>
+          </a:lnRef>
+          <a:fillRef idx="3">
+            <a:schemeClr val="accent1"/>
+          </a:fillRef>
+          <a:effectRef idx="2">
+            <a:schemeClr val="accent1"/>
+          </a:effectRef>
+          <a:fontRef idx="minor">
+            <a:schemeClr val="lt1"/>
+          </a:fontRef>
+        </p:style>
+        <p:txBody>
+          <a:bodyPr rtlCol="0" anchor="ctr"/>
+          <a:lstStyle/>
+          <a:p>
+            <a:pPr algn="ctr"/>
+          </a:p>
+        </p:txBody>
+      </p:sp>
+      <p:sp>
+        <p:nvSpPr>
+          <p:cNvPr id="24" name="TextBox 23"/>
+          <p:cNvSpPr txBox="1"/>
+          <p:nvPr/>
+        </p:nvSpPr>
+        <p:spPr>
+          <a:xfrm>
+            <a:off x="9784080" y="3291840"/>
+            <a:ext cx="2011680" cy="1097280"/>
+          </a:xfrm>
+          <a:prstGeom prst="rect">
+            <a:avLst/>
+          </a:prstGeom>
+          <a:noFill/>
+        </p:spPr>
+        <p:txBody>
+          <a:bodyPr wrap="square">
+            <a:spAutoFit/>
+          </a:bodyPr>
+          <a:lstStyle/>
+          <a:p>
+            <a:pPr algn="ctr"/>
+            <a:r>
+              <a:rPr sz="1100" b="1" i="0">
+                <a:solidFill>
+                  <a:srgbClr val="FFFFFF"/>
+                </a:solidFill>
+                <a:latin typeface="Segoe UI"/>
+              </a:rPr>
+              <a:t>Erick Rodrigues Villalva</a:t>
+            </a:r>
+          </a:p>
+        </p:txBody>
+      </p:sp>
+      <p:sp>
+        <p:nvSpPr>
+          <p:cNvPr id="25" name="TextBox 24"/>
+          <p:cNvSpPr txBox="1"/>
+          <p:nvPr/>
+        </p:nvSpPr>
+        <p:spPr>
+          <a:xfrm>
+            <a:off x="9784080" y="4297680"/>
+            <a:ext cx="2011680" cy="411480"/>
+          </a:xfrm>
+          <a:prstGeom prst="rect">
+            <a:avLst/>
+          </a:prstGeom>
+          <a:noFill/>
+        </p:spPr>
+        <p:txBody>
+          <a:bodyPr wrap="square">
+            <a:spAutoFit/>
+          </a:bodyPr>
+          <a:lstStyle/>
+          <a:p>
+            <a:pPr algn="ctr"/>
+            <a:r>
+              <a:rPr sz="1200" b="1" i="0">
                 <a:solidFill>
                   <a:srgbClr val="FF7B72"/>
                 </a:solidFill>
@@ -3893,7 +4049,7 @@
       </p:sp>
       <p:sp>
         <p:nvSpPr>
-          <p:cNvPr id="22" name="TextBox 21"/>
+          <p:cNvPr id="26" name="TextBox 25"/>
           <p:cNvSpPr txBox="1"/>
           <p:nvPr/>
         </p:nvSpPr>
@@ -4025,7 +4181,7 @@
                 </a:solidFill>
                 <a:latin typeface="Segoe UI"/>
               </a:rPr>
-              <a:t>  PARTE 3 — ANA CAROLINE  —  RA 2486024</a:t>
+              <a:t>  PARTE 4 — ANA CAROLINE  —  RA 2486024</a:t>
             </a:r>
           </a:p>
         </p:txBody>
@@ -8522,7 +8678,7 @@
                 </a:solidFill>
                 <a:latin typeface="Segoe UI"/>
               </a:rPr>
-              <a:t>  PARTE 3 — ANA CAROLINE  —  RA 2486024</a:t>
+              <a:t>  PARTE 4 — ANA CAROLINE  —  RA 2486024</a:t>
             </a:r>
           </a:p>
         </p:txBody>
@@ -9412,7 +9568,7 @@
             <a:avLst/>
           </a:prstGeom>
           <a:solidFill>
-            <a:srgbClr val="FF7B72"/>
+            <a:srgbClr val="3FB950"/>
           </a:solidFill>
           <a:ln>
             <a:noFill/>
@@ -9470,7 +9626,7 @@
                 </a:solidFill>
                 <a:latin typeface="Segoe UI"/>
               </a:rPr>
-              <a:t>  PARTE 4 — ERICK RODRIGUES  —  RA 2301105</a:t>
+              <a:t>  PARTE 4 — ANA CAROLINE  —  RA 2486024</a:t>
             </a:r>
           </a:p>
         </p:txBody>
@@ -9501,7 +9657,7 @@
             <a:r>
               <a:rPr sz="2800" b="1" i="0">
                 <a:solidFill>
-                  <a:srgbClr val="FF7B72"/>
+                  <a:srgbClr val="3FB950"/>
                 </a:solidFill>
                 <a:latin typeface="Segoe UI"/>
               </a:rPr>
@@ -9525,7 +9681,7 @@
             <a:avLst/>
           </a:prstGeom>
           <a:solidFill>
-            <a:srgbClr val="FF7B72"/>
+            <a:srgbClr val="3FB950"/>
           </a:solidFill>
           <a:ln>
             <a:noFill/>
@@ -10693,7 +10849,7 @@
                 </a:solidFill>
                 <a:latin typeface="Segoe UI"/>
               </a:rPr>
-              <a:t>  PARTE 4 — ERICK RODRIGUES  —  RA 2301105</a:t>
+              <a:t>  PARTE 5 — ERICK RODRIGUES  —  RA 2301105</a:t>
             </a:r>
           </a:p>
         </p:txBody>
@@ -11570,7 +11726,7 @@
                 </a:solidFill>
                 <a:latin typeface="Segoe UI"/>
               </a:rPr>
-              <a:t>  PARTE 4 — ERICK RODRIGUES  —  RA 2301105</a:t>
+              <a:t>  PARTE 5 — ERICK RODRIGUES  —  RA 2301105</a:t>
             </a:r>
           </a:p>
         </p:txBody>
@@ -12580,7 +12736,7 @@
                 </a:solidFill>
                 <a:latin typeface="Segoe UI"/>
               </a:rPr>
-              <a:t>  PARTE 4 — ERICK RODRIGUES  —  RA 2301105</a:t>
+              <a:t>  PARTE 5 — ERICK RODRIGUES  —  RA 2301105</a:t>
             </a:r>
           </a:p>
         </p:txBody>
@@ -13973,8 +14129,8 @@
         </p:nvSpPr>
         <p:spPr>
           <a:xfrm>
-            <a:off x="274320" y="5349240"/>
-            <a:ext cx="2743200" cy="1188720"/>
+            <a:off x="182880" y="5349240"/>
+            <a:ext cx="2194560" cy="1188720"/>
           </a:xfrm>
           <a:prstGeom prst="rect">
             <a:avLst/>
@@ -14016,8 +14172,8 @@
         </p:nvSpPr>
         <p:spPr>
           <a:xfrm>
-            <a:off x="274320" y="5349240"/>
-            <a:ext cx="2743200" cy="54864"/>
+            <a:off x="182880" y="5349240"/>
+            <a:ext cx="2194560" cy="54864"/>
           </a:xfrm>
           <a:prstGeom prst="rect">
             <a:avLst/>
@@ -14059,8 +14215,8 @@
         </p:nvSpPr>
         <p:spPr>
           <a:xfrm>
-            <a:off x="384048" y="5422392"/>
-            <a:ext cx="2560320" cy="274320"/>
+            <a:off x="274320" y="5422392"/>
+            <a:ext cx="2011680" cy="274320"/>
           </a:xfrm>
           <a:prstGeom prst="rect">
             <a:avLst/>
@@ -14094,8 +14250,8 @@
         </p:nvSpPr>
         <p:spPr>
           <a:xfrm>
-            <a:off x="365760" y="5715000"/>
-            <a:ext cx="2560320" cy="502920"/>
+            <a:off x="256032" y="5715000"/>
+            <a:ext cx="2057400" cy="502920"/>
           </a:xfrm>
           <a:prstGeom prst="rect">
             <a:avLst/>
@@ -14110,7 +14266,7 @@
           <a:p>
             <a:pPr algn="ctr"/>
             <a:r>
-              <a:rPr sz="1100" b="0" i="0">
+              <a:rPr sz="1000" b="0" i="0">
                 <a:solidFill>
                   <a:srgbClr val="FFFFFF"/>
                 </a:solidFill>
@@ -14129,8 +14285,8 @@
         </p:nvSpPr>
         <p:spPr>
           <a:xfrm>
-            <a:off x="365760" y="6217920"/>
-            <a:ext cx="2560320" cy="274320"/>
+            <a:off x="256032" y="6217920"/>
+            <a:ext cx="2057400" cy="274320"/>
           </a:xfrm>
           <a:prstGeom prst="rect">
             <a:avLst/>
@@ -14145,7 +14301,7 @@
           <a:p>
             <a:pPr algn="ctr"/>
             <a:r>
-              <a:rPr sz="1100" b="0" i="0">
+              <a:rPr sz="1000" b="0" i="0">
                 <a:solidFill>
                   <a:srgbClr val="8B949E"/>
                 </a:solidFill>
@@ -14164,8 +14320,8 @@
         </p:nvSpPr>
         <p:spPr>
           <a:xfrm>
-            <a:off x="3291840" y="5349240"/>
-            <a:ext cx="2743200" cy="1188720"/>
+            <a:off x="2560320" y="5349240"/>
+            <a:ext cx="2194560" cy="1188720"/>
           </a:xfrm>
           <a:prstGeom prst="rect">
             <a:avLst/>
@@ -14207,14 +14363,14 @@
         </p:nvSpPr>
         <p:spPr>
           <a:xfrm>
-            <a:off x="3291840" y="5349240"/>
-            <a:ext cx="2743200" cy="54864"/>
-          </a:xfrm>
-          <a:prstGeom prst="rect">
-            <a:avLst/>
-          </a:prstGeom>
-          <a:solidFill>
-            <a:srgbClr val="BB87FF"/>
+            <a:off x="2560320" y="5349240"/>
+            <a:ext cx="2194560" cy="54864"/>
+          </a:xfrm>
+          <a:prstGeom prst="rect">
+            <a:avLst/>
+          </a:prstGeom>
+          <a:solidFill>
+            <a:srgbClr val="F9A825"/>
           </a:solidFill>
           <a:ln>
             <a:noFill/>
@@ -14250,8 +14406,8 @@
         </p:nvSpPr>
         <p:spPr>
           <a:xfrm>
-            <a:off x="3401568" y="5422392"/>
-            <a:ext cx="2560320" cy="274320"/>
+            <a:off x="2651760" y="5422392"/>
+            <a:ext cx="2011680" cy="274320"/>
           </a:xfrm>
           <a:prstGeom prst="rect">
             <a:avLst/>
@@ -14268,7 +14424,7 @@
             <a:r>
               <a:rPr sz="1000" b="1" i="0">
                 <a:solidFill>
-                  <a:srgbClr val="BB87FF"/>
+                  <a:srgbClr val="F9A825"/>
                 </a:solidFill>
                 <a:latin typeface="Segoe UI"/>
               </a:rPr>
@@ -14285,8 +14441,8 @@
         </p:nvSpPr>
         <p:spPr>
           <a:xfrm>
-            <a:off x="3383280" y="5715000"/>
-            <a:ext cx="2560320" cy="502920"/>
+            <a:off x="2633472" y="5715000"/>
+            <a:ext cx="2057400" cy="502920"/>
           </a:xfrm>
           <a:prstGeom prst="rect">
             <a:avLst/>
@@ -14301,13 +14457,13 @@
           <a:p>
             <a:pPr algn="ctr"/>
             <a:r>
-              <a:rPr sz="1100" b="0" i="0">
+              <a:rPr sz="1000" b="0" i="0">
                 <a:solidFill>
                   <a:srgbClr val="FFFFFF"/>
                 </a:solidFill>
                 <a:latin typeface="Segoe UI"/>
               </a:rPr>
-              <a:t>Karoline Vitória de Freitas Yang</a:t>
+              <a:t>Juliano Barbosa Paixão</a:t>
             </a:r>
           </a:p>
         </p:txBody>
@@ -14320,8 +14476,8 @@
         </p:nvSpPr>
         <p:spPr>
           <a:xfrm>
-            <a:off x="3383280" y="6217920"/>
-            <a:ext cx="2560320" cy="274320"/>
+            <a:off x="2633472" y="6217920"/>
+            <a:ext cx="2057400" cy="274320"/>
           </a:xfrm>
           <a:prstGeom prst="rect">
             <a:avLst/>
@@ -14336,13 +14492,13 @@
           <a:p>
             <a:pPr algn="ctr"/>
             <a:r>
-              <a:rPr sz="1100" b="0" i="0">
+              <a:rPr sz="1000" b="0" i="0">
                 <a:solidFill>
                   <a:srgbClr val="8B949E"/>
                 </a:solidFill>
                 <a:latin typeface="Segoe UI"/>
               </a:rPr>
-              <a:t>RA 2578000</a:t>
+              <a:t>RA 2041952</a:t>
             </a:r>
           </a:p>
         </p:txBody>
@@ -14355,8 +14511,8 @@
         </p:nvSpPr>
         <p:spPr>
           <a:xfrm>
-            <a:off x="6309360" y="5349240"/>
-            <a:ext cx="2743200" cy="1188720"/>
+            <a:off x="4937760" y="5349240"/>
+            <a:ext cx="2194560" cy="1188720"/>
           </a:xfrm>
           <a:prstGeom prst="rect">
             <a:avLst/>
@@ -14398,14 +14554,14 @@
         </p:nvSpPr>
         <p:spPr>
           <a:xfrm>
-            <a:off x="6309360" y="5349240"/>
-            <a:ext cx="2743200" cy="54864"/>
-          </a:xfrm>
-          <a:prstGeom prst="rect">
-            <a:avLst/>
-          </a:prstGeom>
-          <a:solidFill>
-            <a:srgbClr val="3FB950"/>
+            <a:off x="4937760" y="5349240"/>
+            <a:ext cx="2194560" cy="54864"/>
+          </a:xfrm>
+          <a:prstGeom prst="rect">
+            <a:avLst/>
+          </a:prstGeom>
+          <a:solidFill>
+            <a:srgbClr val="BB87FF"/>
           </a:solidFill>
           <a:ln>
             <a:noFill/>
@@ -14441,8 +14597,8 @@
         </p:nvSpPr>
         <p:spPr>
           <a:xfrm>
-            <a:off x="6419088" y="5422392"/>
-            <a:ext cx="2560320" cy="274320"/>
+            <a:off x="5029200" y="5422392"/>
+            <a:ext cx="2011680" cy="274320"/>
           </a:xfrm>
           <a:prstGeom prst="rect">
             <a:avLst/>
@@ -14459,7 +14615,7 @@
             <a:r>
               <a:rPr sz="1000" b="1" i="0">
                 <a:solidFill>
-                  <a:srgbClr val="3FB950"/>
+                  <a:srgbClr val="BB87FF"/>
                 </a:solidFill>
                 <a:latin typeface="Segoe UI"/>
               </a:rPr>
@@ -14476,8 +14632,8 @@
         </p:nvSpPr>
         <p:spPr>
           <a:xfrm>
-            <a:off x="6400800" y="5715000"/>
-            <a:ext cx="2560320" cy="502920"/>
+            <a:off x="5010912" y="5715000"/>
+            <a:ext cx="2057400" cy="502920"/>
           </a:xfrm>
           <a:prstGeom prst="rect">
             <a:avLst/>
@@ -14492,13 +14648,13 @@
           <a:p>
             <a:pPr algn="ctr"/>
             <a:r>
-              <a:rPr sz="1100" b="0" i="0">
+              <a:rPr sz="1000" b="0" i="0">
                 <a:solidFill>
                   <a:srgbClr val="FFFFFF"/>
                 </a:solidFill>
                 <a:latin typeface="Segoe UI"/>
               </a:rPr>
-              <a:t>Ana Caroline Soares Baptista</a:t>
+              <a:t>Karoline Vitória de Freitas Yang</a:t>
             </a:r>
           </a:p>
         </p:txBody>
@@ -14511,8 +14667,8 @@
         </p:nvSpPr>
         <p:spPr>
           <a:xfrm>
-            <a:off x="6400800" y="6217920"/>
-            <a:ext cx="2560320" cy="274320"/>
+            <a:off x="5010912" y="6217920"/>
+            <a:ext cx="2057400" cy="274320"/>
           </a:xfrm>
           <a:prstGeom prst="rect">
             <a:avLst/>
@@ -14527,13 +14683,13 @@
           <a:p>
             <a:pPr algn="ctr"/>
             <a:r>
-              <a:rPr sz="1100" b="0" i="0">
+              <a:rPr sz="1000" b="0" i="0">
                 <a:solidFill>
                   <a:srgbClr val="8B949E"/>
                 </a:solidFill>
                 <a:latin typeface="Segoe UI"/>
               </a:rPr>
-              <a:t>RA 2486024</a:t>
+              <a:t>RA 2578000</a:t>
             </a:r>
           </a:p>
         </p:txBody>
@@ -14546,8 +14702,8 @@
         </p:nvSpPr>
         <p:spPr>
           <a:xfrm>
-            <a:off x="9144000" y="5349240"/>
-            <a:ext cx="2743200" cy="1188720"/>
+            <a:off x="7315200" y="5349240"/>
+            <a:ext cx="2194560" cy="1188720"/>
           </a:xfrm>
           <a:prstGeom prst="rect">
             <a:avLst/>
@@ -14589,14 +14745,14 @@
         </p:nvSpPr>
         <p:spPr>
           <a:xfrm>
-            <a:off x="9144000" y="5349240"/>
-            <a:ext cx="2743200" cy="54864"/>
-          </a:xfrm>
-          <a:prstGeom prst="rect">
-            <a:avLst/>
-          </a:prstGeom>
-          <a:solidFill>
-            <a:srgbClr val="FF7B72"/>
+            <a:off x="7315200" y="5349240"/>
+            <a:ext cx="2194560" cy="54864"/>
+          </a:xfrm>
+          <a:prstGeom prst="rect">
+            <a:avLst/>
+          </a:prstGeom>
+          <a:solidFill>
+            <a:srgbClr val="3FB950"/>
           </a:solidFill>
           <a:ln>
             <a:noFill/>
@@ -14632,8 +14788,8 @@
         </p:nvSpPr>
         <p:spPr>
           <a:xfrm>
-            <a:off x="9253728" y="5422392"/>
-            <a:ext cx="2560320" cy="274320"/>
+            <a:off x="7406640" y="5422392"/>
+            <a:ext cx="2011680" cy="274320"/>
           </a:xfrm>
           <a:prstGeom prst="rect">
             <a:avLst/>
@@ -14650,7 +14806,7 @@
             <a:r>
               <a:rPr sz="1000" b="1" i="0">
                 <a:solidFill>
-                  <a:srgbClr val="FF7B72"/>
+                  <a:srgbClr val="3FB950"/>
                 </a:solidFill>
                 <a:latin typeface="Segoe UI"/>
               </a:rPr>
@@ -14667,8 +14823,8 @@
         </p:nvSpPr>
         <p:spPr>
           <a:xfrm>
-            <a:off x="9235440" y="5715000"/>
-            <a:ext cx="2560320" cy="502920"/>
+            <a:off x="7388352" y="5715000"/>
+            <a:ext cx="2057400" cy="502920"/>
           </a:xfrm>
           <a:prstGeom prst="rect">
             <a:avLst/>
@@ -14683,13 +14839,13 @@
           <a:p>
             <a:pPr algn="ctr"/>
             <a:r>
-              <a:rPr sz="1100" b="0" i="0">
+              <a:rPr sz="1000" b="0" i="0">
                 <a:solidFill>
                   <a:srgbClr val="FFFFFF"/>
                 </a:solidFill>
                 <a:latin typeface="Segoe UI"/>
               </a:rPr>
-              <a:t>Erick Rodrigues Villalva</a:t>
+              <a:t>Ana Caroline Soares Baptista</a:t>
             </a:r>
           </a:p>
         </p:txBody>
@@ -14702,8 +14858,8 @@
         </p:nvSpPr>
         <p:spPr>
           <a:xfrm>
-            <a:off x="9235440" y="6217920"/>
-            <a:ext cx="2560320" cy="274320"/>
+            <a:off x="7388352" y="6217920"/>
+            <a:ext cx="2057400" cy="274320"/>
           </a:xfrm>
           <a:prstGeom prst="rect">
             <a:avLst/>
@@ -14718,12 +14874,203 @@
           <a:p>
             <a:pPr algn="ctr"/>
             <a:r>
-              <a:rPr sz="1100" b="0" i="0">
+              <a:rPr sz="1000" b="0" i="0">
                 <a:solidFill>
                   <a:srgbClr val="8B949E"/>
                 </a:solidFill>
                 <a:latin typeface="Segoe UI"/>
               </a:rPr>
+              <a:t>RA 2486024</a:t>
+            </a:r>
+          </a:p>
+        </p:txBody>
+      </p:sp>
+      <p:sp>
+        <p:nvSpPr>
+          <p:cNvPr id="27" name="Rectangle 26"/>
+          <p:cNvSpPr/>
+          <p:nvPr/>
+        </p:nvSpPr>
+        <p:spPr>
+          <a:xfrm>
+            <a:off x="9692640" y="5349240"/>
+            <a:ext cx="2194560" cy="1188720"/>
+          </a:xfrm>
+          <a:prstGeom prst="rect">
+            <a:avLst/>
+          </a:prstGeom>
+          <a:solidFill>
+            <a:srgbClr val="161B22"/>
+          </a:solidFill>
+          <a:ln>
+            <a:noFill/>
+          </a:ln>
+        </p:spPr>
+        <p:style>
+          <a:lnRef idx="1">
+            <a:schemeClr val="accent1"/>
+          </a:lnRef>
+          <a:fillRef idx="3">
+            <a:schemeClr val="accent1"/>
+          </a:fillRef>
+          <a:effectRef idx="2">
+            <a:schemeClr val="accent1"/>
+          </a:effectRef>
+          <a:fontRef idx="minor">
+            <a:schemeClr val="lt1"/>
+          </a:fontRef>
+        </p:style>
+        <p:txBody>
+          <a:bodyPr rtlCol="0" anchor="ctr"/>
+          <a:lstStyle/>
+          <a:p>
+            <a:pPr algn="ctr"/>
+          </a:p>
+        </p:txBody>
+      </p:sp>
+      <p:sp>
+        <p:nvSpPr>
+          <p:cNvPr id="28" name="Rectangle 27"/>
+          <p:cNvSpPr/>
+          <p:nvPr/>
+        </p:nvSpPr>
+        <p:spPr>
+          <a:xfrm>
+            <a:off x="9692640" y="5349240"/>
+            <a:ext cx="2194560" cy="54864"/>
+          </a:xfrm>
+          <a:prstGeom prst="rect">
+            <a:avLst/>
+          </a:prstGeom>
+          <a:solidFill>
+            <a:srgbClr val="FF7B72"/>
+          </a:solidFill>
+          <a:ln>
+            <a:noFill/>
+          </a:ln>
+        </p:spPr>
+        <p:style>
+          <a:lnRef idx="1">
+            <a:schemeClr val="accent1"/>
+          </a:lnRef>
+          <a:fillRef idx="3">
+            <a:schemeClr val="accent1"/>
+          </a:fillRef>
+          <a:effectRef idx="2">
+            <a:schemeClr val="accent1"/>
+          </a:effectRef>
+          <a:fontRef idx="minor">
+            <a:schemeClr val="lt1"/>
+          </a:fontRef>
+        </p:style>
+        <p:txBody>
+          <a:bodyPr rtlCol="0" anchor="ctr"/>
+          <a:lstStyle/>
+          <a:p>
+            <a:pPr algn="ctr"/>
+          </a:p>
+        </p:txBody>
+      </p:sp>
+      <p:sp>
+        <p:nvSpPr>
+          <p:cNvPr id="29" name="TextBox 28"/>
+          <p:cNvSpPr txBox="1"/>
+          <p:nvPr/>
+        </p:nvSpPr>
+        <p:spPr>
+          <a:xfrm>
+            <a:off x="9784080" y="5422392"/>
+            <a:ext cx="2011680" cy="274320"/>
+          </a:xfrm>
+          <a:prstGeom prst="rect">
+            <a:avLst/>
+          </a:prstGeom>
+          <a:noFill/>
+        </p:spPr>
+        <p:txBody>
+          <a:bodyPr wrap="square">
+            <a:spAutoFit/>
+          </a:bodyPr>
+          <a:lstStyle/>
+          <a:p>
+            <a:pPr algn="ctr"/>
+            <a:r>
+              <a:rPr sz="1000" b="1" i="0">
+                <a:solidFill>
+                  <a:srgbClr val="FF7B72"/>
+                </a:solidFill>
+                <a:latin typeface="Segoe UI"/>
+              </a:rPr>
+              <a:t>Parte 5</a:t>
+            </a:r>
+          </a:p>
+        </p:txBody>
+      </p:sp>
+      <p:sp>
+        <p:nvSpPr>
+          <p:cNvPr id="30" name="TextBox 29"/>
+          <p:cNvSpPr txBox="1"/>
+          <p:nvPr/>
+        </p:nvSpPr>
+        <p:spPr>
+          <a:xfrm>
+            <a:off x="9765792" y="5715000"/>
+            <a:ext cx="2057400" cy="502920"/>
+          </a:xfrm>
+          <a:prstGeom prst="rect">
+            <a:avLst/>
+          </a:prstGeom>
+          <a:noFill/>
+        </p:spPr>
+        <p:txBody>
+          <a:bodyPr wrap="square">
+            <a:spAutoFit/>
+          </a:bodyPr>
+          <a:lstStyle/>
+          <a:p>
+            <a:pPr algn="ctr"/>
+            <a:r>
+              <a:rPr sz="1000" b="0" i="0">
+                <a:solidFill>
+                  <a:srgbClr val="FFFFFF"/>
+                </a:solidFill>
+                <a:latin typeface="Segoe UI"/>
+              </a:rPr>
+              <a:t>Erick Rodrigues Villalva</a:t>
+            </a:r>
+          </a:p>
+        </p:txBody>
+      </p:sp>
+      <p:sp>
+        <p:nvSpPr>
+          <p:cNvPr id="31" name="TextBox 30"/>
+          <p:cNvSpPr txBox="1"/>
+          <p:nvPr/>
+        </p:nvSpPr>
+        <p:spPr>
+          <a:xfrm>
+            <a:off x="9765792" y="6217920"/>
+            <a:ext cx="2057400" cy="274320"/>
+          </a:xfrm>
+          <a:prstGeom prst="rect">
+            <a:avLst/>
+          </a:prstGeom>
+          <a:noFill/>
+        </p:spPr>
+        <p:txBody>
+          <a:bodyPr wrap="square">
+            <a:spAutoFit/>
+          </a:bodyPr>
+          <a:lstStyle/>
+          <a:p>
+            <a:pPr algn="ctr"/>
+            <a:r>
+              <a:rPr sz="1000" b="0" i="0">
+                <a:solidFill>
+                  <a:srgbClr val="8B949E"/>
+                </a:solidFill>
+                <a:latin typeface="Segoe UI"/>
+              </a:rPr>
               <a:t>RA 2301105</a:t>
             </a:r>
           </a:p>
@@ -14731,7 +15078,7 @@
       </p:sp>
       <p:sp>
         <p:nvSpPr>
-          <p:cNvPr id="27" name="TextBox 26"/>
+          <p:cNvPr id="32" name="TextBox 31"/>
           <p:cNvSpPr txBox="1"/>
           <p:nvPr/>
         </p:nvSpPr>
@@ -15290,8 +15637,8 @@
         </p:nvSpPr>
         <p:spPr>
           <a:xfrm>
-            <a:off x="274320" y="1417320"/>
-            <a:ext cx="2743200" cy="4480560"/>
+            <a:off x="182880" y="1417320"/>
+            <a:ext cx="2194560" cy="4480560"/>
           </a:xfrm>
           <a:prstGeom prst="rect">
             <a:avLst/>
@@ -15333,8 +15680,8 @@
         </p:nvSpPr>
         <p:spPr>
           <a:xfrm>
-            <a:off x="274320" y="1417320"/>
-            <a:ext cx="2743200" cy="502920"/>
+            <a:off x="182880" y="1417320"/>
+            <a:ext cx="2194560" cy="502920"/>
           </a:xfrm>
           <a:prstGeom prst="rect">
             <a:avLst/>
@@ -15376,8 +15723,8 @@
         </p:nvSpPr>
         <p:spPr>
           <a:xfrm>
-            <a:off x="365760" y="1435608"/>
-            <a:ext cx="2560320" cy="256032"/>
+            <a:off x="274320" y="1435608"/>
+            <a:ext cx="2011680" cy="256032"/>
           </a:xfrm>
           <a:prstGeom prst="rect">
             <a:avLst/>
@@ -15392,7 +15739,7 @@
           <a:p>
             <a:pPr algn="l"/>
             <a:r>
-              <a:rPr sz="1100" b="1" i="0">
+              <a:rPr sz="1000" b="1" i="0">
                 <a:solidFill>
                   <a:srgbClr val="0D1117"/>
                 </a:solidFill>
@@ -15411,8 +15758,8 @@
         </p:nvSpPr>
         <p:spPr>
           <a:xfrm>
-            <a:off x="365760" y="1691640"/>
-            <a:ext cx="2560320" cy="256032"/>
+            <a:off x="274320" y="1691640"/>
+            <a:ext cx="2011680" cy="256032"/>
           </a:xfrm>
           <a:prstGeom prst="rect">
             <a:avLst/>
@@ -15427,7 +15774,7 @@
           <a:p>
             <a:pPr algn="l"/>
             <a:r>
-              <a:rPr sz="1300" b="1" i="0">
+              <a:rPr sz="1200" b="1" i="0">
                 <a:solidFill>
                   <a:srgbClr val="0D1117"/>
                 </a:solidFill>
@@ -15446,8 +15793,8 @@
         </p:nvSpPr>
         <p:spPr>
           <a:xfrm>
-            <a:off x="365760" y="2011680"/>
-            <a:ext cx="2560320" cy="3657600"/>
+            <a:off x="274320" y="2011680"/>
+            <a:ext cx="2011680" cy="3657600"/>
           </a:xfrm>
           <a:prstGeom prst="rect">
             <a:avLst/>
@@ -15466,13 +15813,13 @@
               </a:spcBef>
             </a:pPr>
             <a:r>
-              <a:rPr sz="1300">
+              <a:rPr sz="1200">
                 <a:solidFill>
                   <a:srgbClr val="FFFFFF"/>
                 </a:solidFill>
                 <a:latin typeface="Segoe UI"/>
               </a:rPr>
-              <a:t>›  Hardware: PIC18F4550, config bits, pinagem</a:t>
+              <a:t>›  Visão geral dos requisitos</a:t>
             </a:r>
           </a:p>
           <a:p>
@@ -15482,13 +15829,13 @@
               </a:spcBef>
             </a:pPr>
             <a:r>
-              <a:rPr sz="1300">
+              <a:rPr sz="1200">
                 <a:solidFill>
                   <a:srgbClr val="FFFFFF"/>
                 </a:solidFill>
                 <a:latin typeface="Segoe UI"/>
               </a:rPr>
-              <a:t>›  Cálculo e configuração do PWM 7 kHz / 38%</a:t>
+              <a:t>›  Timer0: ISR 1 ms, preload 0xFD8F</a:t>
             </a:r>
           </a:p>
           <a:p>
@@ -15498,13 +15845,13 @@
               </a:spcBef>
             </a:pPr>
             <a:r>
-              <a:rPr sz="1300">
+              <a:rPr sz="1200">
                 <a:solidFill>
                   <a:srgbClr val="FFFFFF"/>
                 </a:solidFill>
                 <a:latin typeface="Segoe UI"/>
               </a:rPr>
-              <a:t>›  Funções: init_hardware(), init_pwm()</a:t>
+              <a:t>›  Slides 1–3 e 7 · Conclusão (16)</a:t>
             </a:r>
           </a:p>
         </p:txBody>
@@ -15517,8 +15864,8 @@
         </p:nvSpPr>
         <p:spPr>
           <a:xfrm>
-            <a:off x="3200400" y="1417320"/>
-            <a:ext cx="2743200" cy="4480560"/>
+            <a:off x="2560320" y="1417320"/>
+            <a:ext cx="2194560" cy="4480560"/>
           </a:xfrm>
           <a:prstGeom prst="rect">
             <a:avLst/>
@@ -15560,14 +15907,14 @@
         </p:nvSpPr>
         <p:spPr>
           <a:xfrm>
-            <a:off x="3200400" y="1417320"/>
-            <a:ext cx="2743200" cy="502920"/>
-          </a:xfrm>
-          <a:prstGeom prst="rect">
-            <a:avLst/>
-          </a:prstGeom>
-          <a:solidFill>
-            <a:srgbClr val="BB87FF"/>
+            <a:off x="2560320" y="1417320"/>
+            <a:ext cx="2194560" cy="502920"/>
+          </a:xfrm>
+          <a:prstGeom prst="rect">
+            <a:avLst/>
+          </a:prstGeom>
+          <a:solidFill>
+            <a:srgbClr val="F9A825"/>
           </a:solidFill>
           <a:ln>
             <a:noFill/>
@@ -15603,8 +15950,8 @@
         </p:nvSpPr>
         <p:spPr>
           <a:xfrm>
-            <a:off x="3291840" y="1435608"/>
-            <a:ext cx="2560320" cy="256032"/>
+            <a:off x="2651760" y="1435608"/>
+            <a:ext cx="2011680" cy="256032"/>
           </a:xfrm>
           <a:prstGeom prst="rect">
             <a:avLst/>
@@ -15619,7 +15966,7 @@
           <a:p>
             <a:pPr algn="l"/>
             <a:r>
-              <a:rPr sz="1100" b="1" i="0">
+              <a:rPr sz="1000" b="1" i="0">
                 <a:solidFill>
                   <a:srgbClr val="0D1117"/>
                 </a:solidFill>
@@ -15638,8 +15985,8 @@
         </p:nvSpPr>
         <p:spPr>
           <a:xfrm>
-            <a:off x="3291840" y="1691640"/>
-            <a:ext cx="2560320" cy="256032"/>
+            <a:off x="2651760" y="1691640"/>
+            <a:ext cx="2011680" cy="256032"/>
           </a:xfrm>
           <a:prstGeom prst="rect">
             <a:avLst/>
@@ -15654,13 +16001,13 @@
           <a:p>
             <a:pPr algn="l"/>
             <a:r>
-              <a:rPr sz="1300" b="1" i="0">
+              <a:rPr sz="1200" b="1" i="0">
                 <a:solidFill>
                   <a:srgbClr val="0D1117"/>
                 </a:solidFill>
                 <a:latin typeface="Segoe UI"/>
               </a:rPr>
-              <a:t>KAROLINE</a:t>
+              <a:t>JULIANO</a:t>
             </a:r>
           </a:p>
         </p:txBody>
@@ -15673,8 +16020,8 @@
         </p:nvSpPr>
         <p:spPr>
           <a:xfrm>
-            <a:off x="3291840" y="2011680"/>
-            <a:ext cx="2560320" cy="3657600"/>
+            <a:off x="2651760" y="2011680"/>
+            <a:ext cx="2011680" cy="3657600"/>
           </a:xfrm>
           <a:prstGeom prst="rect">
             <a:avLst/>
@@ -15693,13 +16040,13 @@
               </a:spcBef>
             </a:pPr>
             <a:r>
-              <a:rPr sz="1300">
+              <a:rPr sz="1200">
                 <a:solidFill>
                   <a:srgbClr val="FFFFFF"/>
                 </a:solidFill>
                 <a:latin typeface="Segoe UI"/>
               </a:rPr>
-              <a:t>›  Timer0: ISR de 1 ms, cálculo de recarga</a:t>
+              <a:t>›  Hardware: pinagem PIC18F4550</a:t>
             </a:r>
           </a:p>
           <a:p>
@@ -15709,13 +16056,13 @@
               </a:spcBef>
             </a:pPr>
             <a:r>
-              <a:rPr sz="1300">
+              <a:rPr sz="1200">
                 <a:solidFill>
                   <a:srgbClr val="FFFFFF"/>
                 </a:solidFill>
                 <a:latin typeface="Segoe UI"/>
               </a:rPr>
-              <a:t>›  ADC: leitura do potenciômetro, mapeamento 0–50 °C</a:t>
+              <a:t>›  Config bits + init_hardware()</a:t>
             </a:r>
           </a:p>
           <a:p>
@@ -15725,13 +16072,13 @@
               </a:spcBef>
             </a:pPr>
             <a:r>
-              <a:rPr sz="1300">
+              <a:rPr sz="1200">
                 <a:solidFill>
                   <a:srgbClr val="FFFFFF"/>
                 </a:solidFill>
                 <a:latin typeface="Segoe UI"/>
               </a:rPr>
-              <a:t>›  Função: init_timer0(), init_adc(), ler_adc()</a:t>
+              <a:t>›  PWM: 7 kHz / 38% duty cycle</a:t>
             </a:r>
           </a:p>
         </p:txBody>
@@ -15744,8 +16091,8 @@
         </p:nvSpPr>
         <p:spPr>
           <a:xfrm>
-            <a:off x="6126480" y="1417320"/>
-            <a:ext cx="2743200" cy="4480560"/>
+            <a:off x="4937760" y="1417320"/>
+            <a:ext cx="2194560" cy="4480560"/>
           </a:xfrm>
           <a:prstGeom prst="rect">
             <a:avLst/>
@@ -15787,14 +16134,14 @@
         </p:nvSpPr>
         <p:spPr>
           <a:xfrm>
-            <a:off x="6126480" y="1417320"/>
-            <a:ext cx="2743200" cy="502920"/>
-          </a:xfrm>
-          <a:prstGeom prst="rect">
-            <a:avLst/>
-          </a:prstGeom>
-          <a:solidFill>
-            <a:srgbClr val="3FB950"/>
+            <a:off x="4937760" y="1417320"/>
+            <a:ext cx="2194560" cy="502920"/>
+          </a:xfrm>
+          <a:prstGeom prst="rect">
+            <a:avLst/>
+          </a:prstGeom>
+          <a:solidFill>
+            <a:srgbClr val="BB87FF"/>
           </a:solidFill>
           <a:ln>
             <a:noFill/>
@@ -15830,8 +16177,8 @@
         </p:nvSpPr>
         <p:spPr>
           <a:xfrm>
-            <a:off x="6217920" y="1435608"/>
-            <a:ext cx="2560320" cy="256032"/>
+            <a:off x="5029200" y="1435608"/>
+            <a:ext cx="2011680" cy="256032"/>
           </a:xfrm>
           <a:prstGeom prst="rect">
             <a:avLst/>
@@ -15846,7 +16193,7 @@
           <a:p>
             <a:pPr algn="l"/>
             <a:r>
-              <a:rPr sz="1100" b="1" i="0">
+              <a:rPr sz="1000" b="1" i="0">
                 <a:solidFill>
                   <a:srgbClr val="0D1117"/>
                 </a:solidFill>
@@ -15865,8 +16212,8 @@
         </p:nvSpPr>
         <p:spPr>
           <a:xfrm>
-            <a:off x="6217920" y="1691640"/>
-            <a:ext cx="2560320" cy="256032"/>
+            <a:off x="5029200" y="1691640"/>
+            <a:ext cx="2011680" cy="256032"/>
           </a:xfrm>
           <a:prstGeom prst="rect">
             <a:avLst/>
@@ -15881,13 +16228,13 @@
           <a:p>
             <a:pPr algn="l"/>
             <a:r>
-              <a:rPr sz="1300" b="1" i="0">
+              <a:rPr sz="1200" b="1" i="0">
                 <a:solidFill>
                   <a:srgbClr val="0D1117"/>
                 </a:solidFill>
                 <a:latin typeface="Segoe UI"/>
               </a:rPr>
-              <a:t>ANA CAROLINE</a:t>
+              <a:t>KAROLINE</a:t>
             </a:r>
           </a:p>
         </p:txBody>
@@ -15900,8 +16247,8 @@
         </p:nvSpPr>
         <p:spPr>
           <a:xfrm>
-            <a:off x="6217920" y="2011680"/>
-            <a:ext cx="2560320" cy="3657600"/>
+            <a:off x="5029200" y="2011680"/>
+            <a:ext cx="2011680" cy="3657600"/>
           </a:xfrm>
           <a:prstGeom prst="rect">
             <a:avLst/>
@@ -15920,13 +16267,13 @@
               </a:spcBef>
             </a:pPr>
             <a:r>
-              <a:rPr sz="1300">
+              <a:rPr sz="1200">
                 <a:solidFill>
                   <a:srgbClr val="FFFFFF"/>
                 </a:solidFill>
                 <a:latin typeface="Segoe UI"/>
               </a:rPr>
-              <a:t>›  LCD Miyadaira 4-bit, lcd_inicia(), lcd_posicao()</a:t>
+              <a:t>›  ADC: leitura AN0, mapeamento 0–50 °C</a:t>
             </a:r>
           </a:p>
           <a:p>
@@ -15936,13 +16283,13 @@
               </a:spcBef>
             </a:pPr>
             <a:r>
-              <a:rPr sz="1300">
+              <a:rPr sz="1200">
                 <a:solidFill>
                   <a:srgbClr val="FFFFFF"/>
                 </a:solidFill>
                 <a:latin typeface="Segoe UI"/>
               </a:rPr>
-              <a:t>›  CGRAM: criação de ↑ e ↓ em carregar_chars()</a:t>
+              <a:t>›  LCD Miyadaira: lcd_inicia(), posicao()</a:t>
             </a:r>
           </a:p>
           <a:p>
@@ -15952,13 +16299,13 @@
               </a:spcBef>
             </a:pPr>
             <a:r>
-              <a:rPr sz="1300">
+              <a:rPr sz="1200">
                 <a:solidFill>
                   <a:srgbClr val="FFFFFF"/>
                 </a:solidFill>
                 <a:latin typeface="Segoe UI"/>
               </a:rPr>
-              <a:t>›  Botões: ler_botoes() com debounce de 20 ms</a:t>
+              <a:t>›  Slides 8–9</a:t>
             </a:r>
           </a:p>
         </p:txBody>
@@ -15971,8 +16318,8 @@
         </p:nvSpPr>
         <p:spPr>
           <a:xfrm>
-            <a:off x="9052560" y="1417320"/>
-            <a:ext cx="2743200" cy="4480560"/>
+            <a:off x="7315200" y="1417320"/>
+            <a:ext cx="2194560" cy="4480560"/>
           </a:xfrm>
           <a:prstGeom prst="rect">
             <a:avLst/>
@@ -16014,14 +16361,14 @@
         </p:nvSpPr>
         <p:spPr>
           <a:xfrm>
-            <a:off x="9052560" y="1417320"/>
-            <a:ext cx="2743200" cy="502920"/>
-          </a:xfrm>
-          <a:prstGeom prst="rect">
-            <a:avLst/>
-          </a:prstGeom>
-          <a:solidFill>
-            <a:srgbClr val="FF7B72"/>
+            <a:off x="7315200" y="1417320"/>
+            <a:ext cx="2194560" cy="502920"/>
+          </a:xfrm>
+          <a:prstGeom prst="rect">
+            <a:avLst/>
+          </a:prstGeom>
+          <a:solidFill>
+            <a:srgbClr val="3FB950"/>
           </a:solidFill>
           <a:ln>
             <a:noFill/>
@@ -16057,8 +16404,8 @@
         </p:nvSpPr>
         <p:spPr>
           <a:xfrm>
-            <a:off x="9144000" y="1435608"/>
-            <a:ext cx="2560320" cy="256032"/>
+            <a:off x="7406640" y="1435608"/>
+            <a:ext cx="2011680" cy="256032"/>
           </a:xfrm>
           <a:prstGeom prst="rect">
             <a:avLst/>
@@ -16073,7 +16420,7 @@
           <a:p>
             <a:pPr algn="l"/>
             <a:r>
-              <a:rPr sz="1100" b="1" i="0">
+              <a:rPr sz="1000" b="1" i="0">
                 <a:solidFill>
                   <a:srgbClr val="0D1117"/>
                 </a:solidFill>
@@ -16092,8 +16439,8 @@
         </p:nvSpPr>
         <p:spPr>
           <a:xfrm>
-            <a:off x="9144000" y="1691640"/>
-            <a:ext cx="2560320" cy="256032"/>
+            <a:off x="7406640" y="1691640"/>
+            <a:ext cx="2011680" cy="256032"/>
           </a:xfrm>
           <a:prstGeom prst="rect">
             <a:avLst/>
@@ -16108,13 +16455,13 @@
           <a:p>
             <a:pPr algn="l"/>
             <a:r>
-              <a:rPr sz="1300" b="1" i="0">
+              <a:rPr sz="1200" b="1" i="0">
                 <a:solidFill>
                   <a:srgbClr val="0D1117"/>
                 </a:solidFill>
                 <a:latin typeface="Segoe UI"/>
               </a:rPr>
-              <a:t>ERICK</a:t>
+              <a:t>ANA CAROLINE</a:t>
             </a:r>
           </a:p>
         </p:txBody>
@@ -16127,8 +16474,8 @@
         </p:nvSpPr>
         <p:spPr>
           <a:xfrm>
-            <a:off x="9144000" y="2011680"/>
-            <a:ext cx="2560320" cy="3657600"/>
+            <a:off x="7406640" y="2011680"/>
+            <a:ext cx="2011680" cy="3657600"/>
           </a:xfrm>
           <a:prstGeom prst="rect">
             <a:avLst/>
@@ -16147,13 +16494,13 @@
               </a:spcBef>
             </a:pPr>
             <a:r>
-              <a:rPr sz="1300">
+              <a:rPr sz="1200">
                 <a:solidFill>
                   <a:srgbClr val="FFFFFF"/>
                 </a:solidFill>
                 <a:latin typeface="Segoe UI"/>
               </a:rPr>
-              <a:t>›  Máquina de estados (IDLE→MOVENDO→PORTA→SUPER)</a:t>
+              <a:t>›  CGRAM: chars ↑↓ em 5×8 pixels</a:t>
             </a:r>
           </a:p>
           <a:p>
@@ -16163,13 +16510,13 @@
               </a:spcBef>
             </a:pPr>
             <a:r>
-              <a:rPr sz="1300">
+              <a:rPr sz="1200">
                 <a:solidFill>
                   <a:srgbClr val="FFFFFF"/>
                 </a:solidFill>
                 <a:latin typeface="Segoe UI"/>
               </a:rPr>
-              <a:t>›  Funções motor_liga/desliga(), porta_abre/fecha()</a:t>
+              <a:t>›  Botões: debounce 20 ms</a:t>
             </a:r>
           </a:p>
           <a:p>
@@ -16179,13 +16526,240 @@
               </a:spcBef>
             </a:pPr>
             <a:r>
-              <a:rPr sz="1300">
+              <a:rPr sz="1200">
                 <a:solidFill>
                   <a:srgbClr val="FFFFFF"/>
                 </a:solidFill>
                 <a:latin typeface="Segoe UI"/>
               </a:rPr>
-              <a:t>›  Display: atualizar_lcd() com temperatura e seta</a:t>
+              <a:t>›  Máquina de estados: visão geral</a:t>
+            </a:r>
+          </a:p>
+        </p:txBody>
+      </p:sp>
+      <p:sp>
+        <p:nvSpPr>
+          <p:cNvPr id="26" name="Rectangle 25"/>
+          <p:cNvSpPr/>
+          <p:nvPr/>
+        </p:nvSpPr>
+        <p:spPr>
+          <a:xfrm>
+            <a:off x="9692640" y="1417320"/>
+            <a:ext cx="2194560" cy="4480560"/>
+          </a:xfrm>
+          <a:prstGeom prst="rect">
+            <a:avLst/>
+          </a:prstGeom>
+          <a:solidFill>
+            <a:srgbClr val="161B22"/>
+          </a:solidFill>
+          <a:ln>
+            <a:noFill/>
+          </a:ln>
+        </p:spPr>
+        <p:style>
+          <a:lnRef idx="1">
+            <a:schemeClr val="accent1"/>
+          </a:lnRef>
+          <a:fillRef idx="3">
+            <a:schemeClr val="accent1"/>
+          </a:fillRef>
+          <a:effectRef idx="2">
+            <a:schemeClr val="accent1"/>
+          </a:effectRef>
+          <a:fontRef idx="minor">
+            <a:schemeClr val="lt1"/>
+          </a:fontRef>
+        </p:style>
+        <p:txBody>
+          <a:bodyPr rtlCol="0" anchor="ctr"/>
+          <a:lstStyle/>
+          <a:p>
+            <a:pPr algn="ctr"/>
+          </a:p>
+        </p:txBody>
+      </p:sp>
+      <p:sp>
+        <p:nvSpPr>
+          <p:cNvPr id="27" name="Rectangle 26"/>
+          <p:cNvSpPr/>
+          <p:nvPr/>
+        </p:nvSpPr>
+        <p:spPr>
+          <a:xfrm>
+            <a:off x="9692640" y="1417320"/>
+            <a:ext cx="2194560" cy="502920"/>
+          </a:xfrm>
+          <a:prstGeom prst="rect">
+            <a:avLst/>
+          </a:prstGeom>
+          <a:solidFill>
+            <a:srgbClr val="FF7B72"/>
+          </a:solidFill>
+          <a:ln>
+            <a:noFill/>
+          </a:ln>
+        </p:spPr>
+        <p:style>
+          <a:lnRef idx="1">
+            <a:schemeClr val="accent1"/>
+          </a:lnRef>
+          <a:fillRef idx="3">
+            <a:schemeClr val="accent1"/>
+          </a:fillRef>
+          <a:effectRef idx="2">
+            <a:schemeClr val="accent1"/>
+          </a:effectRef>
+          <a:fontRef idx="minor">
+            <a:schemeClr val="lt1"/>
+          </a:fontRef>
+        </p:style>
+        <p:txBody>
+          <a:bodyPr rtlCol="0" anchor="ctr"/>
+          <a:lstStyle/>
+          <a:p>
+            <a:pPr algn="ctr"/>
+          </a:p>
+        </p:txBody>
+      </p:sp>
+      <p:sp>
+        <p:nvSpPr>
+          <p:cNvPr id="28" name="TextBox 27"/>
+          <p:cNvSpPr txBox="1"/>
+          <p:nvPr/>
+        </p:nvSpPr>
+        <p:spPr>
+          <a:xfrm>
+            <a:off x="9784080" y="1435608"/>
+            <a:ext cx="2011680" cy="256032"/>
+          </a:xfrm>
+          <a:prstGeom prst="rect">
+            <a:avLst/>
+          </a:prstGeom>
+          <a:noFill/>
+        </p:spPr>
+        <p:txBody>
+          <a:bodyPr wrap="square">
+            <a:spAutoFit/>
+          </a:bodyPr>
+          <a:lstStyle/>
+          <a:p>
+            <a:pPr algn="l"/>
+            <a:r>
+              <a:rPr sz="1000" b="1" i="0">
+                <a:solidFill>
+                  <a:srgbClr val="0D1117"/>
+                </a:solidFill>
+                <a:latin typeface="Segoe UI"/>
+              </a:rPr>
+              <a:t>PARTE 5</a:t>
+            </a:r>
+          </a:p>
+        </p:txBody>
+      </p:sp>
+      <p:sp>
+        <p:nvSpPr>
+          <p:cNvPr id="29" name="TextBox 28"/>
+          <p:cNvSpPr txBox="1"/>
+          <p:nvPr/>
+        </p:nvSpPr>
+        <p:spPr>
+          <a:xfrm>
+            <a:off x="9784080" y="1691640"/>
+            <a:ext cx="2011680" cy="256032"/>
+          </a:xfrm>
+          <a:prstGeom prst="rect">
+            <a:avLst/>
+          </a:prstGeom>
+          <a:noFill/>
+        </p:spPr>
+        <p:txBody>
+          <a:bodyPr wrap="square">
+            <a:spAutoFit/>
+          </a:bodyPr>
+          <a:lstStyle/>
+          <a:p>
+            <a:pPr algn="l"/>
+            <a:r>
+              <a:rPr sz="1200" b="1" i="0">
+                <a:solidFill>
+                  <a:srgbClr val="0D1117"/>
+                </a:solidFill>
+                <a:latin typeface="Segoe UI"/>
+              </a:rPr>
+              <a:t>ERICK</a:t>
+            </a:r>
+          </a:p>
+        </p:txBody>
+      </p:sp>
+      <p:sp>
+        <p:nvSpPr>
+          <p:cNvPr id="30" name="TextBox 29"/>
+          <p:cNvSpPr txBox="1"/>
+          <p:nvPr/>
+        </p:nvSpPr>
+        <p:spPr>
+          <a:xfrm>
+            <a:off x="9784080" y="2011680"/>
+            <a:ext cx="2011680" cy="3657600"/>
+          </a:xfrm>
+          <a:prstGeom prst="rect">
+            <a:avLst/>
+          </a:prstGeom>
+          <a:noFill/>
+        </p:spPr>
+        <p:txBody>
+          <a:bodyPr wrap="square">
+            <a:spAutoFit/>
+          </a:bodyPr>
+          <a:lstStyle/>
+          <a:p>
+            <a:pPr algn="l">
+              <a:spcBef>
+                <a:spcPts val="400"/>
+              </a:spcBef>
+            </a:pPr>
+            <a:r>
+              <a:rPr sz="1200">
+                <a:solidFill>
+                  <a:srgbClr val="FFFFFF"/>
+                </a:solidFill>
+                <a:latin typeface="Segoe UI"/>
+              </a:rPr>
+              <a:t>›  Estados IDLE, MOVENDO, RETORNANDO</a:t>
+            </a:r>
+          </a:p>
+          <a:p>
+            <a:pPr algn="l">
+              <a:spcBef>
+                <a:spcPts val="400"/>
+              </a:spcBef>
+            </a:pPr>
+            <a:r>
+              <a:rPr sz="1200">
+                <a:solidFill>
+                  <a:srgbClr val="FFFFFF"/>
+                </a:solidFill>
+                <a:latin typeface="Segoe UI"/>
+              </a:rPr>
+              <a:t>›  PORTA_ABERTA e SUPERAQUECIDO</a:t>
+            </a:r>
+          </a:p>
+          <a:p>
+            <a:pPr algn="l">
+              <a:spcBef>
+                <a:spcPts val="400"/>
+              </a:spcBef>
+            </a:pPr>
+            <a:r>
+              <a:rPr sz="1200">
+                <a:solidFill>
+                  <a:srgbClr val="FFFFFF"/>
+                </a:solidFill>
+                <a:latin typeface="Segoe UI"/>
+              </a:rPr>
+              <a:t>›  atualizar_lcd(): temp sem float</a:t>
             </a:r>
           </a:p>
         </p:txBody>
@@ -16231,7 +16805,7 @@
             <a:avLst/>
           </a:prstGeom>
           <a:solidFill>
-            <a:srgbClr val="58A6FF"/>
+            <a:srgbClr val="F9A825"/>
           </a:solidFill>
           <a:ln>
             <a:noFill/>
@@ -16289,7 +16863,7 @@
                 </a:solidFill>
                 <a:latin typeface="Segoe UI"/>
               </a:rPr>
-              <a:t>  PARTE 1 — WILLIAN DOUGLAS  —  RA 1869027</a:t>
+              <a:t>  PARTE 2 — JULIANO BARBOSA  —  RA 2041952</a:t>
             </a:r>
           </a:p>
         </p:txBody>
@@ -16320,7 +16894,7 @@
             <a:r>
               <a:rPr sz="2800" b="1" i="0">
                 <a:solidFill>
-                  <a:srgbClr val="58A6FF"/>
+                  <a:srgbClr val="F9A825"/>
                 </a:solidFill>
                 <a:latin typeface="Segoe UI"/>
               </a:rPr>
@@ -16344,7 +16918,7 @@
             <a:avLst/>
           </a:prstGeom>
           <a:solidFill>
-            <a:srgbClr val="58A6FF"/>
+            <a:srgbClr val="F9A825"/>
           </a:solidFill>
           <a:ln>
             <a:noFill/>
@@ -18519,7 +19093,7 @@
             <a:avLst/>
           </a:prstGeom>
           <a:solidFill>
-            <a:srgbClr val="58A6FF"/>
+            <a:srgbClr val="F9A825"/>
           </a:solidFill>
           <a:ln>
             <a:noFill/>
@@ -18577,7 +19151,7 @@
                 </a:solidFill>
                 <a:latin typeface="Segoe UI"/>
               </a:rPr>
-              <a:t>  PARTE 1 — WILLIAN DOUGLAS  —  RA 1869027</a:t>
+              <a:t>  PARTE 2 — JULIANO BARBOSA  —  RA 2041952</a:t>
             </a:r>
           </a:p>
         </p:txBody>
@@ -18608,7 +19182,7 @@
             <a:r>
               <a:rPr sz="2800" b="1" i="0">
                 <a:solidFill>
-                  <a:srgbClr val="58A6FF"/>
+                  <a:srgbClr val="F9A825"/>
                 </a:solidFill>
                 <a:latin typeface="Segoe UI"/>
               </a:rPr>
@@ -18632,7 +19206,7 @@
             <a:avLst/>
           </a:prstGeom>
           <a:solidFill>
-            <a:srgbClr val="58A6FF"/>
+            <a:srgbClr val="F9A825"/>
           </a:solidFill>
           <a:ln>
             <a:noFill/>
@@ -19113,7 +19687,7 @@
             <a:avLst/>
           </a:prstGeom>
           <a:solidFill>
-            <a:srgbClr val="58A6FF"/>
+            <a:srgbClr val="F9A825"/>
           </a:solidFill>
           <a:ln>
             <a:noFill/>
@@ -19167,7 +19741,7 @@
             <a:r>
               <a:rPr sz="1400" b="1" i="0">
                 <a:solidFill>
-                  <a:srgbClr val="58A6FF"/>
+                  <a:srgbClr val="F9A825"/>
                 </a:solidFill>
                 <a:latin typeface="Segoe UI"/>
               </a:rPr>
@@ -19448,7 +20022,7 @@
             <a:avLst/>
           </a:prstGeom>
           <a:solidFill>
-            <a:srgbClr val="58A6FF"/>
+            <a:srgbClr val="F9A825"/>
           </a:solidFill>
           <a:ln>
             <a:noFill/>
@@ -19506,7 +20080,7 @@
                 </a:solidFill>
                 <a:latin typeface="Segoe UI"/>
               </a:rPr>
-              <a:t>  PARTE 1 — WILLIAN DOUGLAS  —  RA 1869027</a:t>
+              <a:t>  PARTE 2 — JULIANO BARBOSA  —  RA 2041952</a:t>
             </a:r>
           </a:p>
         </p:txBody>
@@ -19537,7 +20111,7 @@
             <a:r>
               <a:rPr sz="2800" b="1" i="0">
                 <a:solidFill>
-                  <a:srgbClr val="58A6FF"/>
+                  <a:srgbClr val="F9A825"/>
                 </a:solidFill>
                 <a:latin typeface="Segoe UI"/>
               </a:rPr>
@@ -19561,7 +20135,7 @@
             <a:avLst/>
           </a:prstGeom>
           <a:solidFill>
-            <a:srgbClr val="58A6FF"/>
+            <a:srgbClr val="F9A825"/>
           </a:solidFill>
           <a:ln>
             <a:noFill/>
@@ -20974,7 +21548,7 @@
             <a:avLst/>
           </a:prstGeom>
           <a:solidFill>
-            <a:srgbClr val="BB87FF"/>
+            <a:srgbClr val="58A6FF"/>
           </a:solidFill>
           <a:ln>
             <a:noFill/>
@@ -21032,7 +21606,7 @@
                 </a:solidFill>
                 <a:latin typeface="Segoe UI"/>
               </a:rPr>
-              <a:t>  PARTE 2 — KAROLINE VITÓRIA  —  RA 2578000</a:t>
+              <a:t>  PARTE 1 — WILLIAN DOUGLAS  —  RA 1869027</a:t>
             </a:r>
           </a:p>
         </p:txBody>
@@ -21063,7 +21637,7 @@
             <a:r>
               <a:rPr sz="2800" b="1" i="0">
                 <a:solidFill>
-                  <a:srgbClr val="BB87FF"/>
+                  <a:srgbClr val="58A6FF"/>
                 </a:solidFill>
                 <a:latin typeface="Segoe UI"/>
               </a:rPr>
@@ -21087,7 +21661,7 @@
             <a:avLst/>
           </a:prstGeom>
           <a:solidFill>
-            <a:srgbClr val="BB87FF"/>
+            <a:srgbClr val="58A6FF"/>
           </a:solidFill>
           <a:ln>
             <a:noFill/>
@@ -21130,7 +21704,7 @@
             <a:avLst/>
           </a:prstGeom>
           <a:solidFill>
-            <a:srgbClr val="BB87FF"/>
+            <a:srgbClr val="58A6FF"/>
           </a:solidFill>
           <a:ln>
             <a:noFill/>
@@ -21286,7 +21860,7 @@
             <a:avLst/>
           </a:prstGeom>
           <a:solidFill>
-            <a:srgbClr val="BB87FF"/>
+            <a:srgbClr val="58A6FF"/>
           </a:solidFill>
           <a:ln>
             <a:noFill/>
@@ -21442,7 +22016,7 @@
             <a:avLst/>
           </a:prstGeom>
           <a:solidFill>
-            <a:srgbClr val="BB87FF"/>
+            <a:srgbClr val="58A6FF"/>
           </a:solidFill>
           <a:ln>
             <a:noFill/>
@@ -21598,7 +22172,7 @@
             <a:avLst/>
           </a:prstGeom>
           <a:solidFill>
-            <a:srgbClr val="BB87FF"/>
+            <a:srgbClr val="58A6FF"/>
           </a:solidFill>
           <a:ln>
             <a:noFill/>
@@ -22007,7 +22581,7 @@
             <a:avLst/>
           </a:prstGeom>
           <a:solidFill>
-            <a:srgbClr val="BB87FF"/>
+            <a:srgbClr val="58A6FF"/>
           </a:solidFill>
           <a:ln>
             <a:noFill/>
@@ -22061,7 +22635,7 @@
             <a:r>
               <a:rPr sz="1400" b="1" i="0">
                 <a:solidFill>
-                  <a:srgbClr val="BB87FF"/>
+                  <a:srgbClr val="58A6FF"/>
                 </a:solidFill>
                 <a:latin typeface="Segoe UI"/>
               </a:rPr>
@@ -22498,7 +23072,7 @@
                 </a:solidFill>
                 <a:latin typeface="Segoe UI"/>
               </a:rPr>
-              <a:t>  PARTE 2 — KAROLINE VITÓRIA  —  RA 2578000</a:t>
+              <a:t>  PARTE 3 — KAROLINE VITÓRIA  —  RA 2578000</a:t>
             </a:r>
           </a:p>
         </p:txBody>
@@ -23394,7 +23968,7 @@
             <a:avLst/>
           </a:prstGeom>
           <a:solidFill>
-            <a:srgbClr val="3FB950"/>
+            <a:srgbClr val="BB87FF"/>
           </a:solidFill>
           <a:ln>
             <a:noFill/>
@@ -23452,7 +24026,7 @@
                 </a:solidFill>
                 <a:latin typeface="Segoe UI"/>
               </a:rPr>
-              <a:t>  PARTE 3 — ANA CAROLINE  —  RA 2486024</a:t>
+              <a:t>  PARTE 3 — KAROLINE VITÓRIA  —  RA 2578000</a:t>
             </a:r>
           </a:p>
         </p:txBody>
@@ -23483,7 +24057,7 @@
             <a:r>
               <a:rPr sz="2800" b="1" i="0">
                 <a:solidFill>
-                  <a:srgbClr val="3FB950"/>
+                  <a:srgbClr val="BB87FF"/>
                 </a:solidFill>
                 <a:latin typeface="Segoe UI"/>
               </a:rPr>
@@ -23507,7 +24081,7 @@
             <a:avLst/>
           </a:prstGeom>
           <a:solidFill>
-            <a:srgbClr val="3FB950"/>
+            <a:srgbClr val="BB87FF"/>
           </a:solidFill>
           <a:ln>
             <a:noFill/>
@@ -23550,7 +24124,7 @@
             <a:avLst/>
           </a:prstGeom>
           <a:solidFill>
-            <a:srgbClr val="3FB950"/>
+            <a:srgbClr val="BB87FF"/>
           </a:solidFill>
           <a:ln>
             <a:noFill/>
@@ -23593,7 +24167,7 @@
             <a:avLst/>
           </a:prstGeom>
           <a:solidFill>
-            <a:srgbClr val="3FB950"/>
+            <a:srgbClr val="BB87FF"/>
           </a:solidFill>
           <a:ln>
             <a:noFill/>

</xml_diff>

<commit_message>
fix: corrige cor dos slides 2 e 16 para azul (Willian)
Slides 2 (Visao Geral) e 16 (Conclusao) usavam ACCENT amarelo,
mesma cor do Juliano. Trocados para COR_WILLIAN azul.

Co-Authored-By: Claude Sonnet 4.6 (1M context) <noreply@anthropic.com>
</commit_message>
<xml_diff>
--- a/Central_Elevador.pptx
+++ b/Central_Elevador.pptx
@@ -13861,7 +13861,7 @@
             <a:avLst/>
           </a:prstGeom>
           <a:solidFill>
-            <a:srgbClr val="F9A825"/>
+            <a:srgbClr val="58A6FF"/>
           </a:solidFill>
           <a:ln>
             <a:noFill/>
@@ -13897,8 +13897,8 @@
         </p:nvSpPr>
         <p:spPr>
           <a:xfrm>
-            <a:off x="91440" y="45720"/>
-            <a:ext cx="10972800" cy="411480"/>
+            <a:off x="91440" y="18288"/>
+            <a:ext cx="11887200" cy="457200"/>
           </a:xfrm>
           <a:prstGeom prst="rect">
             <a:avLst/>
@@ -13913,13 +13913,13 @@
           <a:p>
             <a:pPr algn="l"/>
             <a:r>
-              <a:rPr sz="1800" b="1" i="0">
+              <a:rPr sz="1600" b="1" i="0">
                 <a:solidFill>
                   <a:srgbClr val="0D1117"/>
                 </a:solidFill>
                 <a:latin typeface="Segoe UI"/>
               </a:rPr>
-              <a:t>  CONCLUSÃO</a:t>
+              <a:t>  PARTE 1 — WILLIAN DOUGLAS  —  RA 1869027</a:t>
             </a:r>
           </a:p>
         </p:txBody>
@@ -13974,7 +13974,7 @@
             <a:avLst/>
           </a:prstGeom>
           <a:solidFill>
-            <a:srgbClr val="F9A825"/>
+            <a:srgbClr val="58A6FF"/>
           </a:solidFill>
           <a:ln>
             <a:noFill/>
@@ -15152,7 +15152,7 @@
             <a:avLst/>
           </a:prstGeom>
           <a:solidFill>
-            <a:srgbClr val="F9A825"/>
+            <a:srgbClr val="58A6FF"/>
           </a:solidFill>
           <a:ln>
             <a:noFill/>
@@ -15188,8 +15188,8 @@
         </p:nvSpPr>
         <p:spPr>
           <a:xfrm>
-            <a:off x="91440" y="45720"/>
-            <a:ext cx="10972800" cy="411480"/>
+            <a:off x="91440" y="18288"/>
+            <a:ext cx="11887200" cy="457200"/>
           </a:xfrm>
           <a:prstGeom prst="rect">
             <a:avLst/>
@@ -15204,13 +15204,13 @@
           <a:p>
             <a:pPr algn="l"/>
             <a:r>
-              <a:rPr sz="1800" b="1" i="0">
+              <a:rPr sz="1600" b="1" i="0">
                 <a:solidFill>
                   <a:srgbClr val="0D1117"/>
                 </a:solidFill>
                 <a:latin typeface="Segoe UI"/>
               </a:rPr>
-              <a:t>  VISÃO GERAL DO PROJETO</a:t>
+              <a:t>  PARTE 1 — WILLIAN DOUGLAS  —  RA 1869027</a:t>
             </a:r>
           </a:p>
         </p:txBody>
@@ -15241,7 +15241,7 @@
             <a:r>
               <a:rPr sz="2600" b="1" i="0">
                 <a:solidFill>
-                  <a:srgbClr val="F9A825"/>
+                  <a:srgbClr val="58A6FF"/>
                 </a:solidFill>
                 <a:latin typeface="Segoe UI"/>
               </a:rPr>
@@ -15265,7 +15265,7 @@
             <a:avLst/>
           </a:prstGeom>
           <a:solidFill>
-            <a:srgbClr val="F9A825"/>
+            <a:srgbClr val="58A6FF"/>
           </a:solidFill>
           <a:ln>
             <a:noFill/>

</xml_diff>